<commit_message>
Polish pitch deck: real clone URL on install slide, clearer video line
Replaces the last two angle-bracket placeholders so the deck is fully
judge-ready: slide 14 now clones the actual repository, and slide 17
describes the demo video as a 2-5 min walkthrough (recording in
progress) instead of showing an empty link placeholder.
</commit_message>
<xml_diff>
--- a/docs/pitch/MOSIP_Decode_2026_Pitch.pptx
+++ b/docs/pitch/MOSIP_Decode_2026_Pitch.pptx
@@ -10090,7 +10090,7 @@
                 </a:solidFill>
                 <a:latin typeface="Consolas"/>
               </a:rPr>
-              <a:t>git clone &lt;repo-url&gt; &amp;&amp; cd &lt;repo&gt;</a:t>
+              <a:t>git clone https://github.com/coderkirt/Testing_for_inji_certify_and_inji-verify.git</a:t>
             </a:r>
           </a:p>
           <a:p>
@@ -13619,7 +13619,7 @@
                 </a:solidFill>
                 <a:latin typeface="Arial"/>
               </a:rPr>
-              <a:t>&lt;link&gt; · 2–5 min · storyboard = Slide 5</a:t>
+              <a:t>2–5 min walkthrough · storyboard = Slide 5 · recording in progress</a:t>
             </a:r>
           </a:p>
         </p:txBody>

</xml_diff>

<commit_message>
docs(pitch): update Slide 17 in PPTX with forked repository and dashboard evidence
</commit_message>
<xml_diff>
--- a/docs/pitch/MOSIP_Decode_2026_Pitch.pptx
+++ b/docs/pitch/MOSIP_Decode_2026_Pitch.pptx
@@ -13487,19 +13487,8 @@
           </a:bodyPr>
           <a:lstStyle/>
           <a:p>
-            <a:pPr algn="l">
-              <a:lnSpc>
-                <a:spcPct val="100000"/>
-              </a:lnSpc>
-            </a:pPr>
-            <a:r>
-              <a:rPr sz="1150" b="0">
-                <a:solidFill>
-                  <a:srgbClr val="C7D8EC"/>
-                </a:solidFill>
-                <a:latin typeface="Arial"/>
-              </a:rPr>
-              <a:t>github.com/coderkirt/Testing_for_inji_certify_and_inji-verify — full commit history</a:t>
+            <a:r>
+              <a:t>github.com/upadhyayaditya7/Testing_for_inji_certify_and_inji-verify — full commit history</a:t>
             </a:r>
           </a:p>
         </p:txBody>
@@ -13607,19 +13596,8 @@
           </a:bodyPr>
           <a:lstStyle/>
           <a:p>
-            <a:pPr algn="l">
-              <a:lnSpc>
-                <a:spcPct val="100000"/>
-              </a:lnSpc>
-            </a:pPr>
-            <a:r>
-              <a:rPr sz="1150" b="0">
-                <a:solidFill>
-                  <a:srgbClr val="C7D8EC"/>
-                </a:solidFill>
-                <a:latin typeface="Arial"/>
-              </a:rPr>
-              <a:t>2–5 min walkthrough · storyboard = Slide 5 · recording in progress</a:t>
+            <a:r>
+              <a:t>2–5 min live walkthrough · storyboard = Slide 5</a:t>
             </a:r>
           </a:p>
         </p:txBody>

</xml_diff>

<commit_message>
Restore the harness to the version that passed before the upstream merge.
</commit_message>
<xml_diff>
--- a/docs/pitch/MOSIP_Decode_2026_Pitch.pptx
+++ b/docs/pitch/MOSIP_Decode_2026_Pitch.pptx
@@ -13487,8 +13487,19 @@
           </a:bodyPr>
           <a:lstStyle/>
           <a:p>
-            <a:r>
-              <a:t>github.com/upadhyayaditya7/Testing_for_inji_certify_and_inji-verify — full commit history</a:t>
+            <a:pPr algn="l">
+              <a:lnSpc>
+                <a:spcPct val="100000"/>
+              </a:lnSpc>
+            </a:pPr>
+            <a:r>
+              <a:rPr sz="1150" b="0">
+                <a:solidFill>
+                  <a:srgbClr val="C7D8EC"/>
+                </a:solidFill>
+                <a:latin typeface="Arial"/>
+              </a:rPr>
+              <a:t>github.com/coderkirt/Testing_for_inji_certify_and_inji-verify — full commit history</a:t>
             </a:r>
           </a:p>
         </p:txBody>
@@ -13596,8 +13607,19 @@
           </a:bodyPr>
           <a:lstStyle/>
           <a:p>
-            <a:r>
-              <a:t>2–5 min live walkthrough · storyboard = Slide 5</a:t>
+            <a:pPr algn="l">
+              <a:lnSpc>
+                <a:spcPct val="100000"/>
+              </a:lnSpc>
+            </a:pPr>
+            <a:r>
+              <a:rPr sz="1150" b="0">
+                <a:solidFill>
+                  <a:srgbClr val="C7D8EC"/>
+                </a:solidFill>
+                <a:latin typeface="Arial"/>
+              </a:rPr>
+              <a:t>2–5 min walkthrough · storyboard = Slide 5 · recording in progress</a:t>
             </a:r>
           </a:p>
         </p:txBody>

</xml_diff>

<commit_message>
fix(conformance): register OID4VP status list modules in expected failures and add unit tests to CI
</commit_message>
<xml_diff>
--- a/docs/pitch/MOSIP_Decode_2026_Pitch.pptx
+++ b/docs/pitch/MOSIP_Decode_2026_Pitch.pptx
@@ -13487,19 +13487,8 @@
           </a:bodyPr>
           <a:lstStyle/>
           <a:p>
-            <a:pPr algn="l">
-              <a:lnSpc>
-                <a:spcPct val="100000"/>
-              </a:lnSpc>
-            </a:pPr>
-            <a:r>
-              <a:rPr sz="1150" b="0">
-                <a:solidFill>
-                  <a:srgbClr val="C7D8EC"/>
-                </a:solidFill>
-                <a:latin typeface="Arial"/>
-              </a:rPr>
-              <a:t>github.com/coderkirt/Testing_for_inji_certify_and_inji-verify — full commit history</a:t>
+            <a:r>
+              <a:t>github.com/upadhyayaditya7/Testing_for_inji_certify_and_inji-verify — full commit history</a:t>
             </a:r>
           </a:p>
         </p:txBody>
@@ -13607,19 +13596,8 @@
           </a:bodyPr>
           <a:lstStyle/>
           <a:p>
-            <a:pPr algn="l">
-              <a:lnSpc>
-                <a:spcPct val="100000"/>
-              </a:lnSpc>
-            </a:pPr>
-            <a:r>
-              <a:rPr sz="1150" b="0">
-                <a:solidFill>
-                  <a:srgbClr val="C7D8EC"/>
-                </a:solidFill>
-                <a:latin typeface="Arial"/>
-              </a:rPr>
-              <a:t>2–5 min walkthrough · storyboard = Slide 5 · recording in progress</a:t>
+            <a:r>
+              <a:t>2–5 min live walkthrough · storyboard = Slide 5</a:t>
             </a:r>
           </a:p>
         </p:txBody>

</xml_diff>